<commit_message>
Slides: condense overlong card copy and re-export PPTX of sd-06-001, 003, 009
Co-Authored-By: Claude Sonnet 5.5 <noreply@anthropic.com>
Claude-Session: https://claude.ai/code/session_01XSxLqDPHaDeZhrxWwesxJf
</commit_message>
<xml_diff>
--- a/system-design-101/vi/lessons/sd-06-001/slides/sd-06-001.pptx
+++ b/system-design-101/vi/lessons/sd-06-001/slides/sd-06-001.pptx
@@ -12677,61 +12677,6 @@
                 <a:cs typeface="Be Vietnam Pro" pitchFamily="34" charset="-120"/>
               </a:rPr>
               <a:t> Logstash</a:t>
-            </a:r>
-            <a:r>
-              <a:rPr lang="en-US" sz="2700" dirty="0" spc="16" kern="0">
-                <a:solidFill>
-                  <a:srgbClr val="14161C"/>
-                </a:solidFill>
-                <a:latin typeface="Be Vietnam Pro" pitchFamily="34" charset="0"/>
-                <a:ea typeface="Be Vietnam Pro" pitchFamily="34" charset="-122"/>
-                <a:cs typeface="Be Vietnam Pro" pitchFamily="34" charset="-120"/>
-              </a:rPr>
-              <a:t> để</a:t>
-            </a:r>
-            <a:r>
-              <a:rPr lang="en-US" sz="2700" dirty="0" spc="-2" kern="0">
-                <a:solidFill>
-                  <a:srgbClr val="14161C"/>
-                </a:solidFill>
-                <a:latin typeface="Be Vietnam Pro" pitchFamily="34" charset="0"/>
-                <a:ea typeface="Be Vietnam Pro" pitchFamily="34" charset="-122"/>
-                <a:cs typeface="Be Vietnam Pro" pitchFamily="34" charset="-120"/>
-              </a:rPr>
-              <a:t> ít</a:t>
-            </a:r>
-            <a:r>
-              <a:rPr lang="en-US" sz="2700" dirty="0" spc="-7" kern="0">
-                <a:solidFill>
-                  <a:srgbClr val="14161C"/>
-                </a:solidFill>
-                <a:latin typeface="Be Vietnam Pro" pitchFamily="34" charset="0"/>
-                <a:ea typeface="Be Vietnam Pro" pitchFamily="34" charset="-122"/>
-                <a:cs typeface="Be Vietnam Pro" pitchFamily="34" charset="-120"/>
-              </a:rPr>
-              <a:t> bỏ</a:t>
-            </a:r>
-            <a:r>
-              <a:rPr lang="en-US" sz="2700" dirty="0" spc="-14" kern="0">
-                <a:solidFill>
-                  <a:srgbClr val="14161C"/>
-                </a:solidFill>
-                <a:latin typeface="Be Vietnam Pro" pitchFamily="34" charset="0"/>
-                <a:ea typeface="Be Vietnam Pro" pitchFamily="34" charset="-122"/>
-                <a:cs typeface="Be Vietnam Pro" pitchFamily="34" charset="-120"/>
-              </a:rPr>
-              <a:t> sót</a:t>
-            </a:r>
-            <a:r>
-              <a:rPr lang="en-US" sz="2700" dirty="0" spc="-6" kern="0">
-                <a:solidFill>
-                  <a:srgbClr val="14161C"/>
-                </a:solidFill>
-                <a:latin typeface="Be Vietnam Pro" pitchFamily="34" charset="0"/>
-                <a:ea typeface="Be Vietnam Pro" pitchFamily="34" charset="-122"/>
-                <a:cs typeface="Be Vietnam Pro" pitchFamily="34" charset="-120"/>
-              </a:rPr>
-              <a:t> log</a:t>
             </a:r>
             <a:endParaRPr lang="en-US" sz="2700" dirty="0"/>
           </a:p>

</xml_diff>

<commit_message>
Slides: condense the remaining overlong lines of sd-06-001 and sd-06-009; re-export PPTX
Co-Authored-By: Claude Sonnet 5.5 <noreply@anthropic.com>
Claude-Session: https://claude.ai/code/session_01XSxLqDPHaDeZhrxWwesxJf
</commit_message>
<xml_diff>
--- a/system-design-101/vi/lessons/sd-06-001/slides/sd-06-001.pptx
+++ b/system-design-101/vi/lessons/sd-06-001/slides/sd-06-001.pptx
@@ -3869,72 +3869,6 @@
               <a:t> đợi</a:t>
             </a:r>
             <a:r>
-              <a:rPr lang="en-US" sz="2550" dirty="0" spc="-5" kern="0">
-                <a:solidFill>
-                  <a:srgbClr val="E4E1D8"/>
-                </a:solidFill>
-                <a:latin typeface="Be Vietnam Pro" pitchFamily="34" charset="0"/>
-                <a:ea typeface="Be Vietnam Pro" pitchFamily="34" charset="-122"/>
-                <a:cs typeface="Be Vietnam Pro" pitchFamily="34" charset="-120"/>
-              </a:rPr>
-              <a:t> bộ</a:t>
-            </a:r>
-            <a:r>
-              <a:rPr lang="en-US" sz="2550" dirty="0" spc="-1" kern="0">
-                <a:solidFill>
-                  <a:srgbClr val="E4E1D8"/>
-                </a:solidFill>
-                <a:latin typeface="Be Vietnam Pro" pitchFamily="34" charset="0"/>
-                <a:ea typeface="Be Vietnam Pro" pitchFamily="34" charset="-122"/>
-                <a:cs typeface="Be Vietnam Pro" pitchFamily="34" charset="-120"/>
-              </a:rPr>
-              <a:t> nhớ</a:t>
-            </a:r>
-            <a:r>
-              <a:rPr lang="en-US" sz="2550" dirty="0" spc="-18" kern="0">
-                <a:solidFill>
-                  <a:srgbClr val="E4E1D8"/>
-                </a:solidFill>
-                <a:latin typeface="Be Vietnam Pro" pitchFamily="34" charset="0"/>
-                <a:ea typeface="Be Vietnam Pro" pitchFamily="34" charset="-122"/>
-                <a:cs typeface="Be Vietnam Pro" pitchFamily="34" charset="-120"/>
-              </a:rPr>
-              <a:t> và</a:t>
-            </a:r>
-            <a:r>
-              <a:rPr lang="en-US" sz="2550" dirty="0" spc="0" kern="0">
-                <a:solidFill>
-                  <a:srgbClr val="E4E1D8"/>
-                </a:solidFill>
-                <a:latin typeface="Be Vietnam Pro" pitchFamily="34" charset="0"/>
-                <a:ea typeface="Be Vietnam Pro" pitchFamily="34" charset="-122"/>
-                <a:cs typeface="Be Vietnam Pro" pitchFamily="34" charset="-120"/>
-              </a:rPr>
-              <a:t> hàng</a:t>
-            </a:r>
-            <a:r>
-              <a:rPr lang="en-US" sz="2550" dirty="0" spc="13" kern="0">
-                <a:solidFill>
-                  <a:srgbClr val="E4E1D8"/>
-                </a:solidFill>
-                <a:latin typeface="Be Vietnam Pro" pitchFamily="34" charset="0"/>
-                <a:ea typeface="Be Vietnam Pro" pitchFamily="34" charset="-122"/>
-                <a:cs typeface="Be Vietnam Pro" pitchFamily="34" charset="-120"/>
-              </a:rPr>
-              <a:t> đợi</a:t>
-            </a:r>
-            <a:r>
-              <a:rPr lang="en-US" sz="2550" dirty="0" spc="26" kern="0">
-                <a:solidFill>
-                  <a:srgbClr val="E4E1D8"/>
-                </a:solidFill>
-                <a:latin typeface="Be Vietnam Pro" pitchFamily="34" charset="0"/>
-                <a:ea typeface="Be Vietnam Pro" pitchFamily="34" charset="-122"/>
-                <a:cs typeface="Be Vietnam Pro" pitchFamily="34" charset="-120"/>
-              </a:rPr>
-              <a:t> đĩa</a:t>
-            </a:r>
-            <a:r>
               <a:rPr lang="en-US" sz="2550" dirty="0" spc="-2" kern="0">
                 <a:solidFill>
                   <a:srgbClr val="E4E1D8"/>
@@ -6156,7 +6090,18 @@
                 <a:ea typeface="Be Vietnam Pro" pitchFamily="34" charset="-122"/>
                 <a:cs typeface="Be Vietnam Pro" pitchFamily="34" charset="-120"/>
               </a:rPr>
-              <a:t> log</a:t>
+              <a:t> log:</a:t>
+            </a:r>
+            <a:r>
+              <a:rPr lang="en-US" sz="2700" dirty="0" spc="0" kern="0">
+                <a:solidFill>
+                  <a:srgbClr val="E4E1D8"/>
+                </a:solidFill>
+                <a:latin typeface="Be Vietnam Pro" pitchFamily="34" charset="0"/>
+                <a:ea typeface="Be Vietnam Pro" pitchFamily="34" charset="-122"/>
+                <a:cs typeface="Be Vietnam Pro" pitchFamily="34" charset="-120"/>
+              </a:rPr>
+              <a:t> thời</a:t>
             </a:r>
             <a:r>
               <a:rPr lang="en-US" sz="2700" dirty="0" spc="-1" kern="0">
@@ -6167,29 +6112,7 @@
                 <a:ea typeface="Be Vietnam Pro" pitchFamily="34" charset="-122"/>
                 <a:cs typeface="Be Vietnam Pro" pitchFamily="34" charset="-120"/>
               </a:rPr>
-              <a:t> thành</a:t>
-            </a:r>
-            <a:r>
-              <a:rPr lang="en-US" sz="2700" dirty="0" spc="5" kern="0">
-                <a:solidFill>
-                  <a:srgbClr val="E4E1D8"/>
-                </a:solidFill>
-                <a:latin typeface="Be Vietnam Pro" pitchFamily="34" charset="0"/>
-                <a:ea typeface="Be Vietnam Pro" pitchFamily="34" charset="-122"/>
-                <a:cs typeface="Be Vietnam Pro" pitchFamily="34" charset="-120"/>
-              </a:rPr>
-              <a:t> trường:</a:t>
-            </a:r>
-            <a:r>
-              <a:rPr lang="en-US" sz="2700" dirty="0" spc="-1" kern="0">
-                <a:solidFill>
-                  <a:srgbClr val="E4E1D8"/>
-                </a:solidFill>
-                <a:latin typeface="Be Vietnam Pro" pitchFamily="34" charset="0"/>
-                <a:ea typeface="Be Vietnam Pro" pitchFamily="34" charset="-122"/>
-                <a:cs typeface="Be Vietnam Pro" pitchFamily="34" charset="-120"/>
-              </a:rPr>
-              <a:t> thời gian,</a:t>
+              <a:t> gian,</a:t>
             </a:r>
             <a:r>
               <a:rPr lang="en-US" sz="2700" dirty="0" spc="9" kern="0">
@@ -9680,7 +9603,7 @@
               <a:t> theo</a:t>
             </a:r>
             <a:r>
-              <a:rPr lang="en-US" sz="2700" dirty="0" spc="0" kern="0">
+              <a:rPr lang="en-US" sz="2700" dirty="0" spc="-1" kern="0">
                 <a:solidFill>
                   <a:srgbClr val="14161C"/>
                 </a:solidFill>
@@ -9688,10 +9611,10 @@
                 <a:ea typeface="Be Vietnam Pro" pitchFamily="34" charset="-122"/>
                 <a:cs typeface="Be Vietnam Pro" pitchFamily="34" charset="-120"/>
               </a:rPr>
-              <a:t> thời</a:t>
-            </a:r>
-            <a:r>
-              <a:rPr lang="en-US" sz="2700" dirty="0" spc="-2" kern="0">
+              <a:t> hạn</a:t>
+            </a:r>
+            <a:r>
+              <a:rPr lang="en-US" sz="2700" dirty="0" spc="-4" kern="0">
                 <a:solidFill>
                   <a:srgbClr val="14161C"/>
                 </a:solidFill>
@@ -9699,10 +9622,10 @@
                 <a:ea typeface="Be Vietnam Pro" pitchFamily="34" charset="-122"/>
                 <a:cs typeface="Be Vietnam Pro" pitchFamily="34" charset="-120"/>
               </a:rPr>
-              <a:t> hạn</a:t>
-            </a:r>
-            <a:r>
-              <a:rPr lang="en-US" sz="2700" dirty="0" spc="-3" kern="0">
+              <a:t> hoặc</a:t>
+            </a:r>
+            <a:r>
+              <a:rPr lang="en-US" sz="2700" dirty="0" spc="-1" kern="0">
                 <a:solidFill>
                   <a:srgbClr val="14161C"/>
                 </a:solidFill>
@@ -9710,10 +9633,10 @@
                 <a:ea typeface="Be Vietnam Pro" pitchFamily="34" charset="-122"/>
                 <a:cs typeface="Be Vietnam Pro" pitchFamily="34" charset="-120"/>
               </a:rPr>
-              <a:t> hoặc</a:t>
-            </a:r>
-            <a:r>
-              <a:rPr lang="en-US" sz="2700" dirty="0" spc="-2" kern="0">
+              <a:t> dung</a:t>
+            </a:r>
+            <a:r>
+              <a:rPr lang="en-US" sz="2700" dirty="0" spc="6" kern="0">
                 <a:solidFill>
                   <a:srgbClr val="14161C"/>
                 </a:solidFill>
@@ -9721,21 +9644,10 @@
                 <a:ea typeface="Be Vietnam Pro" pitchFamily="34" charset="-122"/>
                 <a:cs typeface="Be Vietnam Pro" pitchFamily="34" charset="-120"/>
               </a:rPr>
-              <a:t> dung</a:t>
-            </a:r>
-            <a:r>
-              <a:rPr lang="en-US" sz="2700" dirty="0" spc="6" kern="0">
-                <a:solidFill>
-                  <a:srgbClr val="14161C"/>
-                </a:solidFill>
-                <a:latin typeface="Be Vietnam Pro" pitchFamily="34" charset="0"/>
-                <a:ea typeface="Be Vietnam Pro" pitchFamily="34" charset="-122"/>
-                <a:cs typeface="Be Vietnam Pro" pitchFamily="34" charset="-120"/>
-              </a:rPr>
               <a:t> lượng</a:t>
             </a:r>
             <a:r>
-              <a:rPr lang="en-US" sz="2700" dirty="0" spc="18" kern="0">
+              <a:rPr lang="en-US" sz="2700" dirty="0" spc="17" kern="0">
                 <a:solidFill>
                   <a:srgbClr val="14161C"/>
                 </a:solidFill>
@@ -9984,7 +9896,7 @@
               <a:t> đợi</a:t>
             </a:r>
             <a:r>
-              <a:rPr lang="en-US" sz="2700" dirty="0" spc="-20" kern="0">
+              <a:rPr lang="en-US" sz="2700" dirty="0" spc="-8" kern="0">
                 <a:solidFill>
                   <a:srgbClr val="14161C"/>
                 </a:solidFill>
@@ -9992,10 +9904,10 @@
                 <a:ea typeface="Be Vietnam Pro" pitchFamily="34" charset="-122"/>
                 <a:cs typeface="Be Vietnam Pro" pitchFamily="34" charset="-120"/>
               </a:rPr>
-              <a:t> trong</a:t>
-            </a:r>
-            <a:r>
-              <a:rPr lang="en-US" sz="2700" dirty="0" spc="-7" kern="0">
+              <a:t> bộ</a:t>
+            </a:r>
+            <a:r>
+              <a:rPr lang="en-US" sz="2700" dirty="0" spc="-2" kern="0">
                 <a:solidFill>
                   <a:srgbClr val="14161C"/>
                 </a:solidFill>
@@ -10003,10 +9915,10 @@
                 <a:ea typeface="Be Vietnam Pro" pitchFamily="34" charset="-122"/>
                 <a:cs typeface="Be Vietnam Pro" pitchFamily="34" charset="-120"/>
               </a:rPr>
-              <a:t> bộ</a:t>
-            </a:r>
-            <a:r>
-              <a:rPr lang="en-US" sz="2700" dirty="0" spc="-3" kern="0">
+              <a:t> nhớ</a:t>
+            </a:r>
+            <a:r>
+              <a:rPr lang="en-US" sz="2700" dirty="0" spc="-14" kern="0">
                 <a:solidFill>
                   <a:srgbClr val="14161C"/>
                 </a:solidFill>
@@ -10014,10 +9926,10 @@
                 <a:ea typeface="Be Vietnam Pro" pitchFamily="34" charset="-122"/>
                 <a:cs typeface="Be Vietnam Pro" pitchFamily="34" charset="-120"/>
               </a:rPr>
-              <a:t> nhớ</a:t>
-            </a:r>
-            <a:r>
-              <a:rPr lang="en-US" sz="2700" dirty="0" spc="-13" kern="0">
+              <a:t> mất</a:t>
+            </a:r>
+            <a:r>
+              <a:rPr lang="en-US" sz="2700" dirty="0" spc="-1" kern="0">
                 <a:solidFill>
                   <a:srgbClr val="14161C"/>
                 </a:solidFill>
@@ -10025,10 +9937,10 @@
                 <a:ea typeface="Be Vietnam Pro" pitchFamily="34" charset="-122"/>
                 <a:cs typeface="Be Vietnam Pro" pitchFamily="34" charset="-120"/>
               </a:rPr>
-              <a:t> mất</a:t>
-            </a:r>
-            <a:r>
-              <a:rPr lang="en-US" sz="2700" dirty="0" spc="-2" kern="0">
+              <a:t> khi</a:t>
+            </a:r>
+            <a:r>
+              <a:rPr lang="en-US" sz="2700" dirty="0" spc="-25" kern="0">
                 <a:solidFill>
                   <a:srgbClr val="14161C"/>
                 </a:solidFill>
@@ -10036,7 +9948,7 @@
                 <a:ea typeface="Be Vietnam Pro" pitchFamily="34" charset="-122"/>
                 <a:cs typeface="Be Vietnam Pro" pitchFamily="34" charset="-120"/>
               </a:rPr>
-              <a:t> khi</a:t>
+              <a:t> Logstash</a:t>
             </a:r>
             <a:r>
               <a:rPr lang="en-US" sz="2700" dirty="0" spc="-24" kern="0">
@@ -10047,21 +9959,10 @@
                 <a:ea typeface="Be Vietnam Pro" pitchFamily="34" charset="-122"/>
                 <a:cs typeface="Be Vietnam Pro" pitchFamily="34" charset="-120"/>
               </a:rPr>
-              <a:t> Logstash</a:t>
-            </a:r>
-            <a:r>
-              <a:rPr lang="en-US" sz="2700" dirty="0" spc="-26" kern="0">
-                <a:solidFill>
-                  <a:srgbClr val="14161C"/>
-                </a:solidFill>
-                <a:latin typeface="Be Vietnam Pro" pitchFamily="34" charset="0"/>
-                <a:ea typeface="Be Vietnam Pro" pitchFamily="34" charset="-122"/>
-                <a:cs typeface="Be Vietnam Pro" pitchFamily="34" charset="-120"/>
-              </a:rPr>
               <a:t> tắt</a:t>
             </a:r>
             <a:r>
-              <a:rPr lang="en-US" sz="2700" dirty="0" spc="7" kern="0">
+              <a:rPr lang="en-US" sz="2700" dirty="0" spc="6" kern="0">
                 <a:solidFill>
                   <a:srgbClr val="14161C"/>
                 </a:solidFill>
@@ -10941,7 +10842,7 @@
               <a:t> thêm</a:t>
             </a:r>
             <a:r>
-              <a:rPr lang="en-US" sz="3450" dirty="0" spc="-15" kern="0">
+              <a:rPr lang="en-US" sz="3450" dirty="0" spc="0" kern="0">
                 <a:solidFill>
                   <a:srgbClr val="F3EEE3"/>
                 </a:solidFill>
@@ -10949,10 +10850,10 @@
                 <a:ea typeface="Be Vietnam Pro SemiBold" pitchFamily="34" charset="-122"/>
                 <a:cs typeface="Be Vietnam Pro SemiBold" pitchFamily="34" charset="-120"/>
               </a:rPr>
-              <a:t> vào</a:t>
-            </a:r>
-            <a:r>
-              <a:rPr lang="en-US" sz="3450" dirty="0" spc="1" kern="0">
+              <a:t> là</a:t>
+            </a:r>
+            <a:r>
+              <a:rPr lang="en-US" sz="3450" dirty="0" spc="-11" kern="0">
                 <a:solidFill>
                   <a:srgbClr val="F3EEE3"/>
                 </a:solidFill>
@@ -10960,10 +10861,10 @@
                 <a:ea typeface="Be Vietnam Pro SemiBold" pitchFamily="34" charset="-122"/>
                 <a:cs typeface="Be Vietnam Pro SemiBold" pitchFamily="34" charset="-120"/>
               </a:rPr>
-              <a:t> là</a:t>
-            </a:r>
-            <a:r>
-              <a:rPr lang="en-US" sz="3450" dirty="0" spc="-11" kern="0">
+              <a:t> một</a:t>
+            </a:r>
+            <a:r>
+              <a:rPr lang="en-US" sz="3450" dirty="0" spc="-5" kern="0">
                 <a:solidFill>
                   <a:srgbClr val="F3EEE3"/>
                 </a:solidFill>
@@ -10971,10 +10872,10 @@
                 <a:ea typeface="Be Vietnam Pro SemiBold" pitchFamily="34" charset="-122"/>
                 <a:cs typeface="Be Vietnam Pro SemiBold" pitchFamily="34" charset="-120"/>
               </a:rPr>
-              <a:t> một</a:t>
-            </a:r>
-            <a:r>
-              <a:rPr lang="en-US" sz="3450" dirty="0" spc="-6" kern="0">
+              <a:t> hệ</a:t>
+            </a:r>
+            <a:r>
+              <a:rPr lang="en-US" sz="3450" dirty="0" spc="-9" kern="0">
                 <a:solidFill>
                   <a:srgbClr val="F3EEE3"/>
                 </a:solidFill>
@@ -10982,10 +10883,10 @@
                 <a:ea typeface="Be Vietnam Pro SemiBold" pitchFamily="34" charset="-122"/>
                 <a:cs typeface="Be Vietnam Pro SemiBold" pitchFamily="34" charset="-120"/>
               </a:rPr>
-              <a:t> hệ</a:t>
-            </a:r>
-            <a:r>
-              <a:rPr lang="en-US" sz="3450" dirty="0" spc="-8" kern="0">
+              <a:t> thống</a:t>
+            </a:r>
+            <a:r>
+              <a:rPr lang="en-US" sz="3450" dirty="0" spc="-5" kern="0">
                 <a:solidFill>
                   <a:srgbClr val="F3EEE3"/>
                 </a:solidFill>
@@ -10993,21 +10894,10 @@
                 <a:ea typeface="Be Vietnam Pro SemiBold" pitchFamily="34" charset="-122"/>
                 <a:cs typeface="Be Vietnam Pro SemiBold" pitchFamily="34" charset="-120"/>
               </a:rPr>
-              <a:t> thống</a:t>
-            </a:r>
-            <a:r>
-              <a:rPr lang="en-US" sz="3450" dirty="0" spc="-5" kern="0">
-                <a:solidFill>
-                  <a:srgbClr val="F3EEE3"/>
-                </a:solidFill>
-                <a:latin typeface="Be Vietnam Pro SemiBold" pitchFamily="34" charset="0"/>
-                <a:ea typeface="Be Vietnam Pro SemiBold" pitchFamily="34" charset="-122"/>
-                <a:cs typeface="Be Vietnam Pro SemiBold" pitchFamily="34" charset="-120"/>
-              </a:rPr>
               <a:t> phải</a:t>
             </a:r>
             <a:r>
-              <a:rPr lang="en-US" sz="3450" dirty="0" spc="-17" kern="0">
+              <a:rPr lang="en-US" sz="3450" dirty="0" spc="-16" kern="0">
                 <a:solidFill>
                   <a:srgbClr val="F3EEE3"/>
                 </a:solidFill>

</xml_diff>

<commit_message>
Slides: condense overlong lines of sd-06-001/002/003/009; re-export PPTX
Co-Authored-By: Claude Sonnet 5.5 <noreply@anthropic.com>
Claude-Session: https://claude.ai/code/session_01XSxLqDPHaDeZhrxWwesxJf
</commit_message>
<xml_diff>
--- a/system-design-101/vi/lessons/sd-06-001/slides/sd-06-001.pptx
+++ b/system-design-101/vi/lessons/sd-06-001/slides/sd-06-001.pptx
@@ -4563,17 +4563,6 @@
                 <a:cs typeface="Bricolage Grotesque ExtraBold" pitchFamily="34" charset="-120"/>
               </a:rPr>
               <a:t> bỏ,</a:t>
-            </a:r>
-            <a:r>
-              <a:rPr lang="en-US" sz="9900" dirty="0" spc="1" kern="0">
-                <a:solidFill>
-                  <a:srgbClr val="14161C"/>
-                </a:solidFill>
-                <a:latin typeface="Bricolage Grotesque ExtraBold" pitchFamily="34" charset="0"/>
-                <a:ea typeface="Bricolage Grotesque ExtraBold" pitchFamily="34" charset="-122"/>
-                <a:cs typeface="Bricolage Grotesque ExtraBold" pitchFamily="34" charset="-120"/>
-              </a:rPr>
-              <a:t> chặng</a:t>
             </a:r>
             <a:r>
               <a:rPr lang="en-US" sz="9900" dirty="0" spc="2" kern="0">
@@ -13803,17 +13792,6 @@
                         <a:t> thử ELK;</a:t>
                       </a:r>
                       <a:r>
-                        <a:rPr lang="en-US" sz="3000" dirty="0" spc="-11" kern="0">
-                          <a:solidFill>
-                            <a:srgbClr val="14161C"/>
-                          </a:solidFill>
-                          <a:latin typeface="Be Vietnam Pro" pitchFamily="34" charset="0"/>
-                          <a:ea typeface="Be Vietnam Pro" pitchFamily="34" charset="-122"/>
-                          <a:cs typeface="Be Vietnam Pro" pitchFamily="34" charset="-120"/>
-                        </a:rPr>
-                        <a:t> lấy</a:t>
-                      </a:r>
-                      <a:r>
                         <a:rPr lang="en-US" sz="3000" dirty="0" spc="4" kern="0">
                           <a:solidFill>
                             <a:srgbClr val="14161C"/>

</xml_diff>

<commit_message>
Slides: shorten the last 11- and 12-word lines of sd-06 decks; re-export PPTX
Co-Authored-By: Claude Sonnet 5.5 <noreply@anthropic.com>
Claude-Session: https://claude.ai/code/session_01XSxLqDPHaDeZhrxWwesxJf
</commit_message>
<xml_diff>
--- a/system-design-101/vi/lessons/sd-06-001/slides/sd-06-001.pptx
+++ b/system-design-101/vi/lessons/sd-06-001/slides/sd-06-001.pptx
@@ -2010,7 +2010,7 @@
                 <a:ea typeface="Be Vietnam Pro" pitchFamily="34" charset="-122"/>
                 <a:cs typeface="Be Vietnam Pro" pitchFamily="34" charset="-120"/>
               </a:rPr>
-              <a:t> cho</a:t>
+              <a:t> là gì? Khi</a:t>
             </a:r>
             <a:r>
               <a:rPr lang="en-US" sz="3000" dirty="0" spc="-1" kern="0">
@@ -2021,10 +2021,10 @@
                 <a:ea typeface="Be Vietnam Pro" pitchFamily="34" charset="-122"/>
                 <a:cs typeface="Be Vietnam Pro" pitchFamily="34" charset="-120"/>
               </a:rPr>
-              <a:t> log</a:t>
-            </a:r>
-            <a:r>
-              <a:rPr lang="en-US" sz="3000" dirty="0" spc="0" kern="0">
+              <a:t> nào</a:t>
+            </a:r>
+            <a:r>
+              <a:rPr lang="en-US" sz="3000" dirty="0" spc="-2" kern="0">
                 <a:solidFill>
                   <a:srgbClr val="E4E1D8"/>
                 </a:solidFill>
@@ -2032,54 +2032,10 @@
                 <a:ea typeface="Be Vietnam Pro" pitchFamily="34" charset="-122"/>
                 <a:cs typeface="Be Vietnam Pro" pitchFamily="34" charset="-120"/>
               </a:rPr>
-              <a:t> là</a:t>
-            </a:r>
-            <a:r>
-              <a:rPr lang="en-US" sz="3000" dirty="0" spc="1" kern="0">
-                <a:solidFill>
-                  <a:srgbClr val="E4E1D8"/>
-                </a:solidFill>
-                <a:latin typeface="Be Vietnam Pro" pitchFamily="34" charset="0"/>
-                <a:ea typeface="Be Vietnam Pro" pitchFamily="34" charset="-122"/>
-                <a:cs typeface="Be Vietnam Pro" pitchFamily="34" charset="-120"/>
-              </a:rPr>
-              <a:t> gì?</a:t>
-            </a:r>
-            <a:r>
-              <a:rPr lang="en-US" sz="3000" dirty="0" spc="2" kern="0">
-                <a:solidFill>
-                  <a:srgbClr val="E4E1D8"/>
-                </a:solidFill>
-                <a:latin typeface="Be Vietnam Pro" pitchFamily="34" charset="0"/>
-                <a:ea typeface="Be Vietnam Pro" pitchFamily="34" charset="-122"/>
-                <a:cs typeface="Be Vietnam Pro" pitchFamily="34" charset="-120"/>
-              </a:rPr>
-              <a:t> Khi</a:t>
-            </a:r>
-            <a:r>
-              <a:rPr lang="en-US" sz="3000" dirty="0" spc="-2" kern="0">
-                <a:solidFill>
-                  <a:srgbClr val="E4E1D8"/>
-                </a:solidFill>
-                <a:latin typeface="Be Vietnam Pro" pitchFamily="34" charset="0"/>
-                <a:ea typeface="Be Vietnam Pro" pitchFamily="34" charset="-122"/>
-                <a:cs typeface="Be Vietnam Pro" pitchFamily="34" charset="-120"/>
-              </a:rPr>
-              <a:t> nào</a:t>
-            </a:r>
-            <a:r>
-              <a:rPr lang="en-US" sz="3000" dirty="0" spc="-1" kern="0">
-                <a:solidFill>
-                  <a:srgbClr val="E4E1D8"/>
-                </a:solidFill>
-                <a:latin typeface="Be Vietnam Pro" pitchFamily="34" charset="0"/>
-                <a:ea typeface="Be Vietnam Pro" pitchFamily="34" charset="-122"/>
-                <a:cs typeface="Be Vietnam Pro" pitchFamily="34" charset="-120"/>
-              </a:rPr>
               <a:t> cần</a:t>
             </a:r>
             <a:r>
-              <a:rPr lang="en-US" sz="3000" dirty="0" spc="-46" kern="0">
+              <a:rPr lang="en-US" sz="3000" dirty="0" spc="-45" kern="0">
                 <a:solidFill>
                   <a:srgbClr val="E4E1D8"/>
                 </a:solidFill>
@@ -3328,17 +3284,6 @@
               <a:t> chữ</a:t>
             </a:r>
             <a:r>
-              <a:rPr lang="en-US" sz="2550" dirty="0" spc="0" kern="0">
-                <a:solidFill>
-                  <a:srgbClr val="E4E1D8"/>
-                </a:solidFill>
-                <a:latin typeface="Be Vietnam Pro" pitchFamily="34" charset="0"/>
-                <a:ea typeface="Be Vietnam Pro" pitchFamily="34" charset="-122"/>
-                <a:cs typeface="Be Vietnam Pro" pitchFamily="34" charset="-120"/>
-              </a:rPr>
-              <a:t> cái</a:t>
-            </a:r>
-            <a:r>
               <a:rPr lang="en-US" sz="2550" dirty="0" spc="15" kern="0">
                 <a:solidFill>
                   <a:srgbClr val="E4E1D8"/>
@@ -11780,17 +11725,6 @@
                 <a:cs typeface="Bricolage Grotesque ExtraBold" pitchFamily="34" charset="-120"/>
               </a:rPr>
               <a:t> Khi nào</a:t>
-            </a:r>
-            <a:r>
-              <a:rPr lang="en-US" sz="3600" dirty="0" spc="3" kern="0">
-                <a:solidFill>
-                  <a:srgbClr val="F3EEE3"/>
-                </a:solidFill>
-                <a:latin typeface="Bricolage Grotesque ExtraBold" pitchFamily="34" charset="0"/>
-                <a:ea typeface="Bricolage Grotesque ExtraBold" pitchFamily="34" charset="-122"/>
-                <a:cs typeface="Bricolage Grotesque ExtraBold" pitchFamily="34" charset="-120"/>
-              </a:rPr>
-              <a:t> cần</a:t>
             </a:r>
             <a:r>
               <a:rPr lang="en-US" sz="3600" dirty="0" spc="0" kern="0">
@@ -13325,7 +13259,7 @@
                         <a:buNone/>
                       </a:pPr>
                       <a:r>
-                        <a:rPr lang="en-US" sz="3000" dirty="0" spc="-63" kern="0">
+                        <a:rPr lang="en-US" sz="3000" dirty="0" spc="-53" kern="0">
                           <a:solidFill>
                             <a:srgbClr val="14161C"/>
                           </a:solidFill>
@@ -13333,32 +13267,10 @@
                           <a:ea typeface="Be Vietnam Pro" pitchFamily="34" charset="-122"/>
                           <a:cs typeface="Be Vietnam Pro" pitchFamily="34" charset="-120"/>
                         </a:rPr>
-                        <a:t>Kafka</a:t>
+                        <a:t>Kafka:</a:t>
                       </a:r>
                       <a:r>
                         <a:rPr lang="en-US" sz="3000" dirty="0" spc="3" kern="0">
-                          <a:solidFill>
-                            <a:srgbClr val="14161C"/>
-                          </a:solidFill>
-                          <a:latin typeface="Be Vietnam Pro" pitchFamily="34" charset="0"/>
-                          <a:ea typeface="Be Vietnam Pro" pitchFamily="34" charset="-122"/>
-                          <a:cs typeface="Be Vietnam Pro" pitchFamily="34" charset="-120"/>
-                        </a:rPr>
-                        <a:t> giúp</a:t>
-                      </a:r>
-                      <a:r>
-                        <a:rPr lang="en-US" sz="3000" dirty="0" spc="0" kern="0">
-                          <a:solidFill>
-                            <a:srgbClr val="14161C"/>
-                          </a:solidFill>
-                          <a:latin typeface="Be Vietnam Pro" pitchFamily="34" charset="0"/>
-                          <a:ea typeface="Be Vietnam Pro" pitchFamily="34" charset="-122"/>
-                          <a:cs typeface="Be Vietnam Pro" pitchFamily="34" charset="-120"/>
-                        </a:rPr>
-                        <a:t> nhờ</a:t>
-                      </a:r>
-                      <a:r>
-                        <a:rPr lang="en-US" sz="3000" dirty="0" spc="4" kern="0">
                           <a:solidFill>
                             <a:srgbClr val="14161C"/>
                           </a:solidFill>
@@ -13380,7 +13292,7 @@
                         <a:t> hình</a:t>
                       </a:r>
                       <a:r>
-                        <a:rPr lang="en-US" sz="3000" dirty="0" spc="-36" kern="0">
+                        <a:rPr lang="en-US" sz="3000" dirty="0" spc="-29" kern="0">
                           <a:solidFill>
                             <a:srgbClr val="14161C"/>
                           </a:solidFill>
@@ -13388,40 +13300,7 @@
                           <a:ea typeface="Be Vietnam Pro" pitchFamily="34" charset="-122"/>
                           <a:cs typeface="Be Vietnam Pro" pitchFamily="34" charset="-120"/>
                         </a:rPr>
-                        <a:t> kéo</a:t>
-                      </a:r>
-                      <a:r>
-                        <a:rPr lang="en-US" sz="3000" dirty="0" spc="-19" kern="0">
-                          <a:solidFill>
-                            <a:srgbClr val="14161C"/>
-                          </a:solidFill>
-                          <a:latin typeface="Be Vietnam Pro" pitchFamily="34" charset="0"/>
-                          <a:ea typeface="Be Vietnam Pro" pitchFamily="34" charset="-122"/>
-                          <a:cs typeface="Be Vietnam Pro" pitchFamily="34" charset="-120"/>
-                        </a:rPr>
-                        <a:t> và</a:t>
-                      </a:r>
-                      <a:r>
-                        <a:rPr lang="en-US" sz="3000" dirty="0" spc="2" kern="0">
-                          <a:solidFill>
-                            <a:srgbClr val="14161C"/>
-                          </a:solidFill>
-                          <a:latin typeface="Be Vietnam Pro" pitchFamily="34" charset="0"/>
-                          <a:ea typeface="Be Vietnam Pro" pitchFamily="34" charset="-122"/>
-                          <a:cs typeface="Be Vietnam Pro" pitchFamily="34" charset="-120"/>
-                        </a:rPr>
-                        <a:t> thời</a:t>
-                      </a:r>
-                      <a:r>
-                        <a:rPr lang="en-US" sz="3000" dirty="0" spc="-2" kern="0">
-                          <a:solidFill>
-                            <a:srgbClr val="14161C"/>
-                          </a:solidFill>
-                          <a:latin typeface="Be Vietnam Pro" pitchFamily="34" charset="0"/>
-                          <a:ea typeface="Be Vietnam Pro" pitchFamily="34" charset="-122"/>
-                          <a:cs typeface="Be Vietnam Pro" pitchFamily="34" charset="-120"/>
-                        </a:rPr>
-                        <a:t> hạn</a:t>
+                        <a:t> kéo,</a:t>
                       </a:r>
                       <a:r>
                         <a:rPr lang="en-US" sz="3000" dirty="0" spc="2" kern="0">
@@ -13444,6 +13323,39 @@
                           <a:cs typeface="Be Vietnam Pro" pitchFamily="34" charset="-120"/>
                         </a:rPr>
                         <a:t> log</a:t>
+                      </a:r>
+                      <a:r>
+                        <a:rPr lang="en-US" sz="3000" dirty="0" spc="-4" kern="0">
+                          <a:solidFill>
+                            <a:srgbClr val="14161C"/>
+                          </a:solidFill>
+                          <a:latin typeface="Be Vietnam Pro" pitchFamily="34" charset="0"/>
+                          <a:ea typeface="Be Vietnam Pro" pitchFamily="34" charset="-122"/>
+                          <a:cs typeface="Be Vietnam Pro" pitchFamily="34" charset="-120"/>
+                        </a:rPr>
+                        <a:t> theo</a:t>
+                      </a:r>
+                      <a:r>
+                        <a:rPr lang="en-US" sz="3000" dirty="0" spc="2" kern="0">
+                          <a:solidFill>
+                            <a:srgbClr val="14161C"/>
+                          </a:solidFill>
+                          <a:latin typeface="Be Vietnam Pro" pitchFamily="34" charset="0"/>
+                          <a:ea typeface="Be Vietnam Pro" pitchFamily="34" charset="-122"/>
+                          <a:cs typeface="Be Vietnam Pro" pitchFamily="34" charset="-120"/>
+                        </a:rPr>
+                        <a:t> thời</a:t>
+                      </a:r>
+                      <a:r>
+                        <a:rPr lang="en-US" sz="3000" dirty="0" spc="-3" kern="0">
+                          <a:solidFill>
+                            <a:srgbClr val="14161C"/>
+                          </a:solidFill>
+                          <a:latin typeface="Be Vietnam Pro" pitchFamily="34" charset="0"/>
+                          <a:ea typeface="Be Vietnam Pro" pitchFamily="34" charset="-122"/>
+                          <a:cs typeface="Be Vietnam Pro" pitchFamily="34" charset="-120"/>
+                        </a:rPr>
+                        <a:t> hạn</a:t>
                       </a:r>
                       <a:endParaRPr lang="en-US" sz="1200" dirty="0"/>
                     </a:p>

</xml_diff>